<commit_message>
updated ai-gateway-governane notebook, readme, requirements.txt
</commit_message>
<xml_diff>
--- a/decks/Microsoft Foundry AI Gateway.pptx
+++ b/decks/Microsoft Foundry AI Gateway.pptx
@@ -132,6 +132,83 @@
     </p:ext>
   </p:extLst>
 </p:presentation>
+</file>
+
+<file path=ppt/changesInfos/changesInfo1.xml><?xml version="1.0" encoding="utf-8"?>
+<pc:chgInfo xmlns:a="http://schemas.openxmlformats.org/drawingml/2006/main" xmlns:r="http://schemas.openxmlformats.org/officeDocument/2006/relationships" xmlns:ac="http://schemas.microsoft.com/office/drawing/2013/main/command" xmlns:pc="http://schemas.microsoft.com/office/powerpoint/2013/main/command">
+  <pc:docChgLst>
+    <pc:chgData clId="Web-{7BB7A7A1-4F33-4E43-A809-438E362E12DF}"/>
+    <pc:docChg chg="modSld">
+      <pc:chgData name="" userId="" providerId="" clId="Web-{7BB7A7A1-4F33-4E43-A809-438E362E12DF}" dt="2026-10-14T14:09:33.741" v="0" actId="34807"/>
+      <pc:docMkLst>
+        <pc:docMk/>
+      </pc:docMkLst>
+      <pc:sldChg chg="modNotesTx">
+        <pc:chgData name="" userId="" providerId="" clId="Web-{7BB7A7A1-4F33-4E43-A809-438E362E12DF}" dt="2026-10-14T14:09:33.741" v="0" actId="34807"/>
+        <pc:sldMkLst>
+          <pc:docMk/>
+          <pc:sldMk cId="0" sldId="256"/>
+        </pc:sldMkLst>
+      </pc:sldChg>
+      <pc:sldChg chg="modNotesTx">
+        <pc:chgData name="" userId="" providerId="" clId="Web-{7BB7A7A1-4F33-4E43-A809-438E362E12DF}" dt="2026-10-14T14:09:33.741" v="0" actId="34807"/>
+        <pc:sldMkLst>
+          <pc:docMk/>
+          <pc:sldMk cId="0" sldId="257"/>
+        </pc:sldMkLst>
+      </pc:sldChg>
+      <pc:sldChg chg="modNotesTx">
+        <pc:chgData name="" userId="" providerId="" clId="Web-{7BB7A7A1-4F33-4E43-A809-438E362E12DF}" dt="2026-10-14T14:09:33.741" v="0" actId="34807"/>
+        <pc:sldMkLst>
+          <pc:docMk/>
+          <pc:sldMk cId="0" sldId="258"/>
+        </pc:sldMkLst>
+      </pc:sldChg>
+      <pc:sldChg chg="modNotesTx">
+        <pc:chgData name="" userId="" providerId="" clId="Web-{7BB7A7A1-4F33-4E43-A809-438E362E12DF}" dt="2026-10-14T14:09:33.741" v="0" actId="34807"/>
+        <pc:sldMkLst>
+          <pc:docMk/>
+          <pc:sldMk cId="0" sldId="259"/>
+        </pc:sldMkLst>
+      </pc:sldChg>
+      <pc:sldChg chg="modNotesTx">
+        <pc:chgData name="" userId="" providerId="" clId="Web-{7BB7A7A1-4F33-4E43-A809-438E362E12DF}" dt="2026-10-14T14:09:33.741" v="0" actId="34807"/>
+        <pc:sldMkLst>
+          <pc:docMk/>
+          <pc:sldMk cId="0" sldId="260"/>
+        </pc:sldMkLst>
+      </pc:sldChg>
+      <pc:sldChg chg="modNotesTx">
+        <pc:chgData name="" userId="" providerId="" clId="Web-{7BB7A7A1-4F33-4E43-A809-438E362E12DF}" dt="2026-10-14T14:09:33.741" v="0" actId="34807"/>
+        <pc:sldMkLst>
+          <pc:docMk/>
+          <pc:sldMk cId="0" sldId="261"/>
+        </pc:sldMkLst>
+      </pc:sldChg>
+      <pc:sldChg chg="modNotesTx">
+        <pc:chgData name="" userId="" providerId="" clId="Web-{7BB7A7A1-4F33-4E43-A809-438E362E12DF}" dt="2026-10-14T14:09:33.741" v="0" actId="34807"/>
+        <pc:sldMkLst>
+          <pc:docMk/>
+          <pc:sldMk cId="0" sldId="262"/>
+        </pc:sldMkLst>
+      </pc:sldChg>
+      <pc:sldChg chg="modNotesTx">
+        <pc:chgData name="" userId="" providerId="" clId="Web-{7BB7A7A1-4F33-4E43-A809-438E362E12DF}" dt="2026-10-14T14:09:33.741" v="0" actId="34807"/>
+        <pc:sldMkLst>
+          <pc:docMk/>
+          <pc:sldMk cId="0" sldId="263"/>
+        </pc:sldMkLst>
+      </pc:sldChg>
+      <pc:sldChg chg="modNotesTx">
+        <pc:chgData name="" userId="" providerId="" clId="Web-{7BB7A7A1-4F33-4E43-A809-438E362E12DF}" dt="2026-10-14T14:09:33.741" v="0" actId="34807"/>
+        <pc:sldMkLst>
+          <pc:docMk/>
+          <pc:sldMk cId="0" sldId="264"/>
+        </pc:sldMkLst>
+      </pc:sldChg>
+    </pc:docChg>
+  </pc:docChgLst>
+</pc:chgInfo>
 </file>
 
 <file path=ppt/notesMasters/notesMaster1.xml><?xml version="1.0" encoding="utf-8"?>
@@ -304,28 +381,18 @@
           <a:lstStyle/>
           <a:p>
             <a:r>
-              <a:t>This session is about one question that comes up as soon as more than one team builds on Foundry: how do we govern who uses which models, tools and agents, and how much?</a:t>
-            </a:r>
-          </a:p>
-          <a:p>
-            <a:r>
-              <a:t>The answer Microsoft documents is an AI gateway, built on Azure API Management. Three things carry that name, and I will separate them on slide 3. The AI Gateway feature in the Foundry portal is preview. The AI policies inside API Management, such as token limits and content safety, are generally available. And there is a new, separate AI Gateway tier of API Management, also preview.</a:t>
-            </a:r>
-          </a:p>
-          <a:p>
-            <a:r>
-              <a:t>The plan: the problem, the three meanings of the term, the architecture, then governance for models, tools and agents in turn, a comparison with the other controls it is confused with, and finally how this scales across many teams.</a:t>
-            </a:r>
-          </a:p>
-          <a:p>
-            <a:r>
-              <a:t>Every fact was checked against Microsoft Learn on 3 October 2026. Anything marked with an asterisk is preview, with no service level agreement.</a:t>
-            </a:r>
-          </a:p>
-          <a:p>
-            <a:r>
-              <a:t>Likely question: do we need API Management skills to use the Foundry feature? For token limits, no; the portal creates and configures the instance. For tool and MCP policies, yes, they are edited in the Azure portal.</a:t>
-            </a:r>
+              <a:rPr lang="en-US"/>
+              <a:t>This session covers the AI gateway in Microsoft Foundry, and one question that comes up as soon as more than one team builds on Foundry: how to govern who uses which models, tools and agents, and how much.
+The answer Microsoft documents is an AI gateway, built on Azure API Management. Three things carry that name, and slide 3 separates them. The AI Gateway feature in the Foundry portal is in preview. The AI policies inside API Management, such as token limits and content safety, are generally available. And there is a new, separate AI Gateway tier of API Management, also in preview.
+We begin with the problem the gateway solves, and then the three meanings of the term.
+We then examine the architecture of AI Gateway in Foundry.
+The third section covers governance for models, tools and agents in turn.
+The fourth section compares the gateway with the other controls it is often confused with, and we close with how this scales across many teams.
+Every fact was checked against the official Microsoft documentation on 3 October 2026. Anything marked with an asterisk is in preview, with no service level agreement.
+A common question is whether the Foundry feature requires API Management skills. For token limits it does not: the Foundry portal creates and configures the API Management instance. For tool and MCP policies it does, because those policies are edited in the Azure portal.
+The overall narrative is simple: once several teams share Foundry, a single governed entry point decides who uses which models, tools and agents, and how much, and the session moves from the problem to the architecture, the governance of each building block, the comparison with other controls and the pattern at scale.</a:t>
+            </a:r>
+            <a:endParaRPr/>
           </a:p>
         </p:txBody>
       </p:sp>
@@ -394,28 +461,19 @@
           <a:lstStyle/>
           <a:p>
             <a:r>
-              <a:t>The takeaway: once several teams share models, tools and agents, direct access stops scaling, and a gateway puts one control point in the path.</a:t>
-            </a:r>
-          </a:p>
-          <a:p>
-            <a:r>
-              <a:t>On the left is direct access. Every application or agent calls every backend itself. Four problems follow. Capacity is shared, so one project can use it all; Learn calls the fix multi-team token containment. Token cost can't be attributed to a team. Credentials are spread across clients. And tools and agents appear without any register.</a:t>
-            </a:r>
-          </a:p>
-          <a:p>
-            <a:r>
-              <a:t>On the right, an AI gateway built on Azure API Management sits in the request path. Learn describes it as sitting between clients and Foundry building blocks, including models and tools. Policies run on every request: token limits, usage metrics, content safety, and managed identity from the gateway to the backends, so clients don't hold model keys.</a:t>
-            </a:r>
-          </a:p>
-          <a:p>
-            <a:r>
-              <a:t>The cost is real: an extra network hop, one more component to make highly available, and a component that sees every prompt. The Architecture Center guide on gateways says not to add one if it puts latency or reliability targets at risk.</a:t>
-            </a:r>
-          </a:p>
-          <a:p>
-            <a:r>
-              <a:t>Likely question: does this replace Foundry quota? No. Quota sets capacity; the gateway divides it. Slide 8 compares them.</a:t>
-            </a:r>
+              <a:rPr lang="en-US"/>
+              <a:t>This slide compares direct access with access through an AI gateway. Read it as two halves: direct access on the left, and one governed entry point on the right.
+The core idea is that once several teams share models, tools and agents, direct access stops scaling, and a gateway puts one control point in the request path.
+First, direct access.
+Every application or agent calls every backend itself. Four problems follow. Capacity is shared, so one project can use all of it; the official documentation calls the fix multi-team token containment. Token cost cannot be attributed to a team. Credentials are spread across clients. And tools and agents appear without any register.
+Second, the AI gateway.
+An AI gateway built on Azure API Management sits in the request path. The official documentation describes it as sitting between clients and Foundry building blocks, including models and tools. Policies run on every request: token limits, usage metrics, content safety, and managed identity from the gateway to the backends, so clients do not hold model keys.
+Third, the cost of the gateway.
+The cost is real. It adds an extra network hop, one more component to make highly available, and a component that sees every prompt. The Architecture Center guide on gateways advises against adding one if it puts latency or reliability targets at risk.
+A common question is whether the gateway replaces Foundry quota. It does not: quota sets capacity, and the gateway divides it among consumers. Slide 8 compares the two in detail.
+The key takeaway is that a gateway is worth its extra hop once several teams share capacity, credentials and tools, because it turns four unmanaged problems into policies enforced at one point.</a:t>
+            </a:r>
+            <a:endParaRPr/>
           </a:p>
         </p:txBody>
       </p:sp>
@@ -484,33 +542,20 @@
           <a:lstStyle/>
           <a:p>
             <a:r>
-              <a:t>Customers use "AI gateway" for three different things, so it pays to fix the terms first.</a:t>
-            </a:r>
-          </a:p>
-          <a:p>
-            <a:r>
-              <a:t>Column one, AI Gateway in Foundry. In the Foundry portal, under Manage, AI Gateway, an administrator connects an API Management instance to a Foundry resource, either a new Basic v2 instance or an existing v2 instance in the same tenant and subscription. All projects in that resource share the gateway, and each project gets its own token limits. It is preview in the Foundry feature-readiness table.</a:t>
-            </a:r>
-          </a:p>
-          <a:p>
-            <a:r>
-              <a:t>Column two, the AI gateway capabilities of API Management itself. Learn says these are not a separate offering: they are policies such as llm-token-limit and llm-content-safety, plus MCP and A2A support, configured in the Azure portal. They are generally available.</a:t>
-            </a:r>
-          </a:p>
-          <a:p>
-            <a:r>
-              <a:t>Column three is a new, separate AI Gateway tier with its own portal, in preview in two regions.</a:t>
-            </a:r>
-          </a:p>
-          <a:p>
-            <a:r>
-              <a:t>Presenter note: verify AI Gateway in Foundry status before presenting; the configuration page carries no preview label, while the readiness table marks it preview.</a:t>
-            </a:r>
-          </a:p>
-          <a:p>
-            <a:r>
-              <a:t>Likely question: can several Foundry resources share one gateway? Not through the Foundry feature; that needs standalone API Management, as slide 9 shows.</a:t>
-            </a:r>
+              <a:rPr lang="en-US"/>
+              <a:t>This slide compares the three offerings that share the name AI gateway in Azure. Read it from left to right, one offering per column, with the rows asking the same questions of each.
+The core idea is that customers use the term for three different things, so the terms have to be fixed first.
+First, AI Gateway in Foundry.
+In the Foundry portal, under Manage, AI Gateway, an administrator connects an API Management instance to a Foundry resource. This is either a new Basic v2 instance or an existing v2 instance in the same tenant and subscription. All projects in that resource share the gateway, and each project gets its own token limits. It is marked as preview in the Foundry feature-readiness table. However, the configuration page carries no preview label, so the status of AI Gateway in Foundry should be confirmed before presenting.
+Second, the AI gateway capabilities of API Management itself.
+As per official documentation, these are not a separate offering. They are policies such as llm-token-limit and llm-content-safety, plus MCP and A2A support, configured in the Azure portal. They are generally available.
+Third, the AI Gateway tier.
+This is a new, separate tier of API Management with its own portal. It is in preview, in two regions only, East US 2 and Sweden Central. The deck mentions it for completeness only.
+For the rest of the deck, "AI Gateway in Foundry" refers to the Foundry portal feature, and "API Management policies" refers to policies configured directly in API Management.
+A common question is whether several Foundry resources can share one gateway. They cannot through the Foundry feature; that needs standalone API Management, as slide 9 shows.
+The key takeaway is that the three offerings differ in where policies are configured and in what they govern, so it is worth naming which one is meant before any design discussion.</a:t>
+            </a:r>
+            <a:endParaRPr/>
           </a:p>
         </p:txBody>
       </p:sp>
@@ -579,33 +624,24 @@
           <a:lstStyle/>
           <a:p>
             <a:r>
-              <a:t>This diagram is AI Gateway in Foundry, column one on slide 3. Underneath is a standard API Management instance, so the box shows two groups of settings.</a:t>
-            </a:r>
-          </a:p>
-          <a:p>
-            <a:r>
-              <a:t>The upper group is set in the Foundry portal: token limits and quotas per project, routing of new MCP tools, and registration of custom agents. All three are preview.</a:t>
-            </a:r>
-          </a:p>
-          <a:p>
-            <a:r>
-              <a:t>The lower group is configured directly in API Management, in the Azure portal. Learn documents this for MCP tools routed through the gateway. Presenter note: verify before presenting whether adding policies such as semantic caching or content safety to model traffic managed by the Foundry gateway is supported; Learn doesn't describe it.</a:t>
-            </a:r>
-          </a:p>
-          <a:p>
-            <a:r>
-              <a:t>Step one: callers sign in with Microsoft Entra ID. Step two: requests go to the gateway URL; Learn lists bypassed requests as a troubleshooting case. Step three: policies run and the gateway forwards to the project's model deployments, the MCP server or the registered agent. Step four: metrics and logs go to Azure Monitor, and inventory appears in the Control Plane.</a:t>
-            </a:r>
-          </a:p>
-          <a:p>
-            <a:r>
-              <a:t>Presenter note: verify whether Foundry agents' own model calls route through the gateway.</a:t>
-            </a:r>
-          </a:p>
-          <a:p>
-            <a:r>
-              <a:t>Likely question: does this cover several Foundry resources? No; that needs standalone API Management, slide 9.</a:t>
-            </a:r>
+              <a:rPr lang="en-US"/>
+              <a:t>This slide shows the architecture of AI Gateway in Foundry, column one on slide 3. Read it as four numbered steps, from the caller through the gateway to the backend and on to the governance services.
+The core idea is that underneath the feature is a standard API Management instance, so the gateway box shows two groups of settings.
+The upper group is set in the Foundry portal: token limits and quotas per project, routing of new MCP tools, and registration of custom agents. All three are in preview.
+The lower group is configured directly in API Management, in the Azure portal. The official documentation describes this for MCP tools routed through the gateway. It does not describe adding policies such as semantic caching or content safety to model traffic managed by the Foundry gateway, so whether that is supported should be confirmed before presenting.
+First, callers sign in.
+Applications, agents and developer tools authenticate with Microsoft Entra ID.
+Second, requests go to the gateway URL.
+Requests are sent to the gateway URL, not to the backend. The official documentation lists bypassed requests as a troubleshooting case.
+Third, policies run and the gateway forwards.
+The gateway forwards each request to the project's model deployments, the MCP server or the registered agent.
+Fourth, telemetry reaches the governance services.
+Metrics and logs go to Azure Monitor, and inventory appears in the Foundry Control Plane.
+It is also not yet clear whether the model calls made by Foundry agents themselves route through the gateway, so this should be confirmed before presenting.
+A common question is whether this design covers several Foundry resources. It does not; that needs standalone API Management, as slide 9 shows.
+The architectural principle is one API Management instance per Foundry resource: the Foundry portal sets the per-project limits and registrations, API Management carries the remaining policies, and every request passes through the gateway URL.</a:t>
+            </a:r>
+            <a:endParaRPr/>
           </a:p>
         </p:txBody>
       </p:sp>
@@ -674,38 +710,22 @@
           <a:lstStyle/>
           <a:p>
             <a:r>
-              <a:t>Most organisations start with models, because shared capacity and cost hurt first.</a:t>
-            </a:r>
-          </a:p>
-          <a:p>
-            <a:r>
-              <a:t>The table lists the documented API Management policies. llm-token-limit enforces tokens per minute, returning 429, and a token quota over a period from hourly to yearly, returning 403. The counter key can be any expression, such as subscription, IP address or a header. It can also estimate prompt tokens before calling the backend, so an oversized prompt is rejected early.</a:t>
-            </a:r>
-          </a:p>
-          <a:p>
-            <a:r>
-              <a:t>llm-emit-token-metric sends token counts to Azure Monitor with up to five custom dimensions, which is how cost is attributed to teams.</a:t>
-            </a:r>
-          </a:p>
-          <a:p>
-            <a:r>
-              <a:t>Two caveats. Token counts are tracked per gateway, not aggregated across regional gateways. And v2 tiers use a token-bucket algorithm, unlike the sliding window in classic tiers.</a:t>
-            </a:r>
-          </a:p>
-          <a:p>
-            <a:r>
-              <a:t>The card on the right is the Foundry route: the same limits set per project and deployment in the portal, with no XML. Learn warns that concurrent requests can briefly exceed limits.</a:t>
-            </a:r>
-          </a:p>
-          <a:p>
-            <a:r>
-              <a:t>Presenter note: verify the code sample against the llm-token-limit reference before showing it; values are illustrative.</a:t>
-            </a:r>
-          </a:p>
-          <a:p>
-            <a:r>
-              <a:t>Likely question: does caching work for all prompts? Only semantically similar ones, and it requires Azure Managed Redis or another RediSearch-compatible cache.</a:t>
-            </a:r>
+              <a:rPr lang="en-US"/>
+              <a:t>This slide lists the controls the gateway applies to model traffic. Read the table from top to bottom, then the example policy and the Foundry card beside it.
+The core idea is that most organisations start with models, because shared capacity and cost hurt first.
+First, token limits and quotas.
+The table lists the documented API Management policies. llm-token-limit enforces a limit in tokens per minute, returning 429 when it is exceeded, and a token quota over a period from hourly to yearly, returning 403. The counter key can be any expression, such as the subscription, the IP address or a header. The policy can also estimate prompt tokens before calling the backend, so an oversized prompt is rejected early.
+Second, token metrics.
+llm-emit-token-metric sends token counts to Azure Monitor with up to five custom dimensions. This is how cost is attributed to teams.
+Two caveats apply. Token counts are tracked per gateway, not aggregated across regional gateways. And v2 tiers use a token-bucket algorithm, which differs from the sliding window in classic tiers.
+Third, the example policy.
+The code sample shows these policies together. The values are illustrative, and the sample should be confirmed against the llm-token-limit reference before presenting it.
+Fourth, the Foundry route.
+The card on the right sets the same limits per project and deployment in the Foundry portal, with no XML. The official documentation warns that concurrent requests can briefly exceed the limits.
+A common question is whether semantic caching works for all prompts. It does not: only semantically similar prompts are served from the cache, and it requires Azure Managed Redis or another RediSearch-compatible cache.
+The key takeaway is that token limits contain consumption and token metrics attribute it, and both can be set either as API Management policies or, for per-project limits, directly in the Foundry portal.</a:t>
+            </a:r>
+            <a:endParaRPr/>
           </a:p>
         </p:txBody>
       </p:sp>
@@ -774,38 +794,19 @@
           <a:lstStyle/>
           <a:p>
             <a:r>
-              <a:t>Every MCP server an agent can call is a new path to data and actions.</a:t>
-            </a:r>
-          </a:p>
-          <a:p>
-            <a:r>
-              <a:t>The three columns follow the order Microsoft's guidance suggests: register, govern, consume.</a:t>
-            </a:r>
-          </a:p>
-          <a:p>
-            <a:r>
-              <a:t>Column one, Azure API Center, is the inventory: an MCP registry endpoint for Visual Studio Code and GitHub Copilot, sync from API Management, and a feed into Foundry tool catalogs.</a:t>
-            </a:r>
-          </a:p>
-          <a:p>
-            <a:r>
-              <a:t>Column two, API Management, does the enforcement. It can turn existing REST API operations into MCP tools, or pass traffic through to an existing MCP server. Policies apply to all tools of a server. Since June 2026 the content safety policy also inspects MCP tool arguments and responses.</a:t>
-            </a:r>
-          </a:p>
-          <a:p>
-            <a:r>
-              <a:t>Column three is the Foundry route, in preview. Only new MCP tools created in the Foundry portal without managed OAuth are routed; Foundry rewrites the endpoint to the gateway URL. Built-in tools such as SharePoint, code-first MCP and OpenAPI tools are not covered, existing tools are not migrated, and the gateway doesn't log tool traces.</a:t>
-            </a:r>
-          </a:p>
-          <a:p>
-            <a:r>
-              <a:t>Presenter note: verify API Center MCP registry status; no first-party general-availability statement was found.</a:t>
-            </a:r>
-          </a:p>
-          <a:p>
-            <a:r>
-              <a:t>Likely question: can policies differ per tool? Currently policies apply to all operations exposed as tools in one MCP server.</a:t>
-            </a:r>
+              <a:rPr lang="en-US"/>
+              <a:t>This slide explains how MCP servers and tools are governed. Read it from left to right as three columns that follow the order Microsoft's guidance suggests: register, govern, consume.
+The core idea is that every MCP server an agent can call is a new path to data and actions.
+First, the registry in Azure API Center.
+This is the inventory. It provides an MCP registry endpoint for Visual Studio Code and GitHub Copilot, synchronisation from API Management, and a feed into Foundry tool catalogs. No first-party statement of general availability was found for the API Center MCP registry, so its status should be confirmed before presenting.
+Second, the gateway in API Management.
+This is where enforcement happens. API Management can turn existing REST API operations into MCP tools, or pass traffic through to an existing MCP server. Policies apply to all tools of a server. Since June 2026, the content safety policy also inspects MCP tool arguments and responses.
+Third, Foundry tools through AI Gateway.
+This is the Foundry route, in preview. Only new MCP tools created in the Foundry portal without managed OAuth are routed, and Foundry rewrites the tool endpoint to the gateway URL. However, coverage is narrow. Built-in tools such as SharePoint, code-first MCP and OpenAPI tools are not covered, existing tools are not migrated, and the gateway does not log tool traces.
+A common question is whether policies can differ per tool. Currently they cannot: policies apply to all operations exposed as tools in one MCP server.
+The key takeaway is to register MCP servers first, then govern access at the gateway, and only then let agents consume them from the catalog, bearing in mind that the Foundry route covers new MCP tools only.</a:t>
+            </a:r>
+            <a:endParaRPr/>
           </a:p>
         </p:txBody>
       </p:sp>
@@ -874,43 +875,22 @@
           <a:lstStyle/>
           <a:p>
             <a:r>
-              <a:t>Agents need two kinds of governance: inventory, and control of their traffic.</a:t>
-            </a:r>
-          </a:p>
-          <a:p>
-            <a:r>
-              <a:t>Column one, custom agents registered in the Foundry Control Plane. Foundry uses API Management as a proxy and issues a new URL that clients must use. HTTP and A2A are supported. Foundry can't start or stop an agent it doesn't host, but it can block incoming requests, which is the off switch for a misbehaving agent.</a:t>
-            </a:r>
-          </a:p>
-          <a:p>
-            <a:r>
-              <a:t>Column two, external agents, is lighter: Foundry stores registration metadata and receives OpenTelemetry traces, but traffic doesn't pass through the gateway.</a:t>
-            </a:r>
-          </a:p>
-          <a:p>
-            <a:r>
-              <a:t>Column three, A2A agent APIs imported directly into API Management, generally available since June 2026. JSON-RPC only; the agent card is rewritten to point at the gateway.</a:t>
-            </a:r>
-          </a:p>
-          <a:p>
-            <a:r>
-              <a:t>Column four covers the models agents call. With a bring-your-own-model connection, prompt agents use deployments named connection-slash-model, routed through API Management. It requires the OpenAI-compatible chat completions API.</a:t>
-            </a:r>
-          </a:p>
-          <a:p>
-            <a:r>
-              <a:t>The band is the important caveat: Foundry guardrails cover only Foundry Agent Service agents.</a:t>
-            </a:r>
-          </a:p>
-          <a:p>
-            <a:r>
-              <a:t>Presenter note: verify the status of bring-your-own-model; release notes say generally available, but one Learn page labels it preview.</a:t>
-            </a:r>
-          </a:p>
-          <a:p>
-            <a:r>
-              <a:t>Likely question: can hosted agents use this? The documented model-gateway route supports prompt agents only.</a:t>
-            </a:r>
+              <a:rPr lang="en-US"/>
+              <a:t>This slide compares four mechanisms that bring agents and their traffic under central control. Read it from left to right: each column has a different traffic path.
+The core idea is that agents need two kinds of governance: inventory, and control of their traffic.
+First, custom agents registered in the Foundry Control Plane.
+Foundry uses API Management as a proxy and issues a new URL that clients must use. HTTP and A2A are supported. Foundry cannot start or stop an agent it does not host, but it can block incoming requests, which is the off switch for a misbehaving agent.
+Second, external agents.
+This mechanism is lighter. Foundry stores registration metadata and receives OpenTelemetry traces, but traffic does not pass through the gateway.
+Third, A2A agent APIs in API Management.
+These are imported directly into API Management and have been generally available since June 2026. They support JSON-RPC only, and the agent card is rewritten to point at the gateway.
+Fourth, the model calls that agents make.
+With a connection that brings the customer's own model, prompt agents use deployments named connection slash model, routed through API Management. It requires the OpenAI-compatible chat completions API. The release notes describe this own-model connection as generally available, while one page of the official documentation labels it preview, so its status should be confirmed before presenting.
+The band at the bottom carries the important caveat: Foundry guardrails cover only agents built in Foundry Agent Service. For registered custom agents, content safety at the gateway is the documented runtime control.
+A common question is whether hosted agents can use the model gateway. The documented model-gateway route supports prompt agents only.
+The key takeaway is that registration alone gives inventory, not control: only the mechanisms that put the gateway in the traffic path can block, filter or meter what an agent does.</a:t>
+            </a:r>
+            <a:endParaRPr/>
           </a:p>
         </p:txBody>
       </p:sp>
@@ -979,43 +959,23 @@
           <a:lstStyle/>
           <a:p>
             <a:r>
-              <a:t>This answers the common question: "we have quota and guardrails, why a gateway?"</a:t>
-            </a:r>
-          </a:p>
-          <a:p>
-            <a:r>
-              <a:t>Read across the rows. Foundry quota is the capacity a deployment receives from Azure, in tokens per minute, per subscription and region.</a:t>
-            </a:r>
-          </a:p>
-          <a:p>
-            <a:r>
-              <a:t>AI Gateway token limits divide that capacity among projects on a shared gateway: 429 over the per-minute limit, 403 over the period quota. That is the multi-team containment quota can't give you.</a:t>
-            </a:r>
-          </a:p>
-          <a:p>
-            <a:r>
-              <a:t>API Management policies are broader: any counter key, content safety, caching and routing, and they reach MCP and A2A traffic.</a:t>
-            </a:r>
-          </a:p>
-          <a:p>
-            <a:r>
-              <a:t>Foundry guardrails filter content: harmful categories, prompt attacks, PII and task adherence. They are generally available for models and preview for agents, and they don't cover agents registered from outside Foundry Agent Service.</a:t>
-            </a:r>
-          </a:p>
-          <a:p>
-            <a:r>
-              <a:t>Azure Policy and RBAC decide who may create, configure and call resources; they don't inspect individual requests.</a:t>
-            </a:r>
-          </a:p>
-          <a:p>
-            <a:r>
-              <a:t>Presenter note: verify guardrail status for agents on the guardrails overview page before presenting.</a:t>
-            </a:r>
-          </a:p>
-          <a:p>
-            <a:r>
-              <a:t>Likely question: should content safety run in both guardrails and the gateway? For Foundry agents, guardrails are the primary control; the gateway policy adds coverage for traffic guardrails don't see.</a:t>
-            </a:r>
+              <a:rPr lang="en-US"/>
+              <a:t>This slide compares AI Gateway token limits with the other governance controls they are often confused with. Read across the rows: each column is one control, asked the same questions.
+The core idea is that it answers the common question: "we have quota and guardrails, so why a gateway?"
+First, Foundry quota.
+It is the capacity a deployment receives from Azure, in tokens per minute, per subscription and region.
+Second, AI Gateway token limits.
+They divide that capacity among projects on a shared gateway, returning 429 over the per-minute limit and 403 over the period quota. This is the multi-team containment that quota cannot provide.
+Third, API Management policies.
+They are broader: any counter key, content safety, caching and routing, and they reach MCP and A2A traffic.
+Fourth, Foundry guardrails.
+They filter content: harmful categories, prompt attacks, PII and task adherence. They are generally available for models and in preview for agents, and they do not cover agents registered from outside Foundry Agent Service. The guardrail status for agents should be confirmed on the guardrails overview page before presenting.
+Fifth, Azure Policy and RBAC.
+They decide who may create, configure and call resources. However, they do not inspect individual requests.
+A common question is whether content safety should run in both the guardrails and the gateway. For Foundry agents, guardrails are the primary control; the gateway policy adds coverage for traffic that guardrails do not see.
+The key takeaway is that the controls stack rather than replace each other: quota sets capacity, gateway limits divide it among consumers, guardrails and content safety filter content, and Azure Policy and RBAC govern who can create and configure resources.</a:t>
+            </a:r>
+            <a:endParaRPr/>
           </a:p>
         </p:txBody>
       </p:sp>
@@ -1084,33 +1044,21 @@
           <a:lstStyle/>
           <a:p>
             <a:r>
-              <a:t>Closing on scale. The Foundry Citadel platform on GitHub, an Azure-Samples reference, describes a hub-and-spoke pattern.</a:t>
-            </a:r>
-          </a:p>
-          <a:p>
-            <a:r>
-              <a:t>Step one: each business unit works in its own spoke, a Foundry resource with its projects, and sends AI traffic to the central hub. Step two: the hub, API Management with API Center as the registry, applies common policies and forwards to shared models, tools and agents. Step three: telemetry and inventory flow up to Foundry Control Plane, Microsoft Entra for agent identity, and Defender and Purview. It is an opinionated sample, not a product; I left out its market statistics.</a:t>
-            </a:r>
-          </a:p>
-          <a:p>
-            <a:r>
-              <a:t>On the right, the constraints. The Foundry AI Gateway serves one Foundry resource, so a hub spanning many spokes is standalone API Management. Private Foundry needs Standard v2 or Premium v2. Token counts are per gateway.</a:t>
-            </a:r>
-          </a:p>
-          <a:p>
-            <a:r>
-              <a:t>For one app and one model, or for throttling alone, a gateway adds a hop without benefit.</a:t>
-            </a:r>
-          </a:p>
-          <a:p>
-            <a:r>
-              <a:t>Presenter note: verify the Citadel repository and aka.ms/ai-hub-gateway are current before sharing links.</a:t>
-            </a:r>
-          </a:p>
-          <a:p>
-            <a:r>
-              <a:t>Likely question: where should we start? Enable AI Gateway in Foundry on one resource with token limits, then move to a standalone hub when a second resource arrives.</a:t>
-            </a:r>
+              <a:rPr lang="en-US"/>
+              <a:t>This slide closes on governance at scale. Read the diagram as three numbered steps, then the design constraints and the cases where a gateway is not needed.
+The core idea is that each business unit builds in its own spoke, while a central hub applies common policies to all AI traffic. The Foundry Citadel platform on GitHub, an Azure-Samples reference, describes this hub-and-spoke pattern.
+First, the spokes.
+Each business unit works in its own spoke, a Foundry resource with its projects, and sends AI traffic to the central hub.
+Second, the governance hub.
+The hub is API Management, with API Center as the registry. It applies common policies and forwards requests to shared models, tools and agents.
+Third, the governance layer.
+Telemetry and inventory flow up to the Foundry Control Plane, Microsoft Entra for agent identity, and Defender and Purview. It is an opinionated sample, not a product, and its market statistics are deliberately left out of this deck. The Citadel repository and aka.ms/ai-hub-gateway should be confirmed as current before the links are shared.
+The design constraints are on the right. AI Gateway in Foundry serves one Foundry resource, so a hub spanning many spokes is standalone API Management. A private Foundry deployment needs Standard v2 or Premium v2. Token counts are kept per gateway.
+For one application and one model, or for throttling alone, a gateway adds a hop without benefit.
+A common question is where to start. The answer is to enable AI Gateway in Foundry on one resource with token limits, and then move to a standalone hub when a second resource arrives.
+The key takeaway is to start small with AI Gateway in Foundry on a single resource, and to move to a standalone API Management hub only when governance has to span several Foundry resources.</a:t>
+            </a:r>
+            <a:endParaRPr/>
           </a:p>
         </p:txBody>
       </p:sp>
@@ -1313,7 +1261,7 @@
           <a:p>
             <a:fld id="{5BCAD085-E8A6-8845-BD4E-CB4CCA059FC4}" type="datetimeFigureOut">
               <a:rPr lang="en-US" smtClean="0"/>
-              <a:t>10/11/2026</a:t>
+              <a:t>10/14/2026</a:t>
             </a:fld>
             <a:endParaRPr lang="en-US"/>
           </a:p>
@@ -1481,7 +1429,7 @@
           <a:p>
             <a:fld id="{5BCAD085-E8A6-8845-BD4E-CB4CCA059FC4}" type="datetimeFigureOut">
               <a:rPr lang="en-US" smtClean="0"/>
-              <a:t>10/11/2026</a:t>
+              <a:t>10/14/2026</a:t>
             </a:fld>
             <a:endParaRPr lang="en-US"/>
           </a:p>
@@ -1659,7 +1607,7 @@
           <a:p>
             <a:fld id="{5BCAD085-E8A6-8845-BD4E-CB4CCA059FC4}" type="datetimeFigureOut">
               <a:rPr lang="en-US" smtClean="0"/>
-              <a:t>10/11/2026</a:t>
+              <a:t>10/14/2026</a:t>
             </a:fld>
             <a:endParaRPr lang="en-US"/>
           </a:p>
@@ -1827,7 +1775,7 @@
           <a:p>
             <a:fld id="{5BCAD085-E8A6-8845-BD4E-CB4CCA059FC4}" type="datetimeFigureOut">
               <a:rPr lang="en-US" smtClean="0"/>
-              <a:t>10/11/2026</a:t>
+              <a:t>10/14/2026</a:t>
             </a:fld>
             <a:endParaRPr lang="en-US"/>
           </a:p>
@@ -2072,7 +2020,7 @@
           <a:p>
             <a:fld id="{5BCAD085-E8A6-8845-BD4E-CB4CCA059FC4}" type="datetimeFigureOut">
               <a:rPr lang="en-US" smtClean="0"/>
-              <a:t>10/11/2026</a:t>
+              <a:t>10/14/2026</a:t>
             </a:fld>
             <a:endParaRPr lang="en-US"/>
           </a:p>
@@ -2357,7 +2305,7 @@
           <a:p>
             <a:fld id="{5BCAD085-E8A6-8845-BD4E-CB4CCA059FC4}" type="datetimeFigureOut">
               <a:rPr lang="en-US" smtClean="0"/>
-              <a:t>10/11/2026</a:t>
+              <a:t>10/14/2026</a:t>
             </a:fld>
             <a:endParaRPr lang="en-US"/>
           </a:p>
@@ -2776,7 +2724,7 @@
           <a:p>
             <a:fld id="{5BCAD085-E8A6-8845-BD4E-CB4CCA059FC4}" type="datetimeFigureOut">
               <a:rPr lang="en-US" smtClean="0"/>
-              <a:t>10/11/2026</a:t>
+              <a:t>10/14/2026</a:t>
             </a:fld>
             <a:endParaRPr lang="en-US"/>
           </a:p>
@@ -2893,7 +2841,7 @@
           <a:p>
             <a:fld id="{5BCAD085-E8A6-8845-BD4E-CB4CCA059FC4}" type="datetimeFigureOut">
               <a:rPr lang="en-US" smtClean="0"/>
-              <a:t>10/11/2026</a:t>
+              <a:t>10/14/2026</a:t>
             </a:fld>
             <a:endParaRPr lang="en-US"/>
           </a:p>
@@ -2988,7 +2936,7 @@
           <a:p>
             <a:fld id="{5BCAD085-E8A6-8845-BD4E-CB4CCA059FC4}" type="datetimeFigureOut">
               <a:rPr lang="en-US" smtClean="0"/>
-              <a:t>10/11/2026</a:t>
+              <a:t>10/14/2026</a:t>
             </a:fld>
             <a:endParaRPr lang="en-US"/>
           </a:p>
@@ -3263,7 +3211,7 @@
           <a:p>
             <a:fld id="{5BCAD085-E8A6-8845-BD4E-CB4CCA059FC4}" type="datetimeFigureOut">
               <a:rPr lang="en-US" smtClean="0"/>
-              <a:t>10/11/2026</a:t>
+              <a:t>10/14/2026</a:t>
             </a:fld>
             <a:endParaRPr lang="en-US"/>
           </a:p>
@@ -3515,7 +3463,7 @@
           <a:p>
             <a:fld id="{5BCAD085-E8A6-8845-BD4E-CB4CCA059FC4}" type="datetimeFigureOut">
               <a:rPr lang="en-US" smtClean="0"/>
-              <a:t>10/11/2026</a:t>
+              <a:t>10/14/2026</a:t>
             </a:fld>
             <a:endParaRPr lang="en-US"/>
           </a:p>
@@ -3726,7 +3674,7 @@
           <a:p>
             <a:fld id="{5BCAD085-E8A6-8845-BD4E-CB4CCA059FC4}" type="datetimeFigureOut">
               <a:rPr lang="en-US" smtClean="0"/>
-              <a:t>10/11/2026</a:t>
+              <a:t>10/14/2026</a:t>
             </a:fld>
             <a:endParaRPr lang="en-US"/>
           </a:p>

</xml_diff>